<commit_message>
Rajout de pdf au cas ou powerpoint ne fonctionne pas
</commit_message>
<xml_diff>
--- a/fichiers/presentation/PresGlobal.pptx
+++ b/fichiers/presentation/PresGlobal.pptx
@@ -1467,13 +1467,8 @@
         <a:p>
           <a:r>
             <a:rPr lang="fr-FR" dirty="0"/>
-            <a:t>2h - </a:t>
+            <a:t>2h - PUILLLE</a:t>
           </a:r>
-          <a:r>
-            <a:rPr lang="fr-FR" dirty="0" err="1"/>
-            <a:t>Salopeir</a:t>
-          </a:r>
-          <a:endParaRPr lang="fr-FR" dirty="0"/>
         </a:p>
       </dgm:t>
     </dgm:pt>
@@ -2759,13 +2754,8 @@
           </a:pPr>
           <a:r>
             <a:rPr lang="fr-FR" sz="1100" kern="1200" dirty="0"/>
-            <a:t>2h - </a:t>
+            <a:t>2h - PUILLLE</a:t>
           </a:r>
-          <a:r>
-            <a:rPr lang="fr-FR" sz="1100" kern="1200" dirty="0" err="1"/>
-            <a:t>Salopeir</a:t>
-          </a:r>
-          <a:endParaRPr lang="fr-FR" sz="1100" kern="1200" dirty="0"/>
         </a:p>
       </dsp:txBody>
       <dsp:txXfrm>
@@ -4929,7 +4919,7 @@
           <a:p>
             <a:fld id="{1438A7C7-51D5-4CE9-848C-73CCDCB5AD2A}" type="datetimeFigureOut">
               <a:rPr lang="fr-FR" smtClean="0"/>
-              <a:t>06/06/2026</a:t>
+              <a:t>08/06/2026</a:t>
             </a:fld>
             <a:endParaRPr lang="fr-FR"/>
           </a:p>
@@ -5365,7 +5355,7 @@
           <a:p>
             <a:fld id="{25BF4BE5-493C-4950-8611-4B73EBA124A3}" type="datetime1">
               <a:rPr lang="fr-FR" smtClean="0"/>
-              <a:t>06/06/2026</a:t>
+              <a:t>08/06/2026</a:t>
             </a:fld>
             <a:endParaRPr lang="fr-FR"/>
           </a:p>
@@ -5719,7 +5709,7 @@
           <a:p>
             <a:fld id="{7440509C-B4B3-4DBB-BCC9-40D57FCA4C66}" type="datetime1">
               <a:rPr lang="fr-FR" smtClean="0"/>
-              <a:t>06/06/2026</a:t>
+              <a:t>08/06/2026</a:t>
             </a:fld>
             <a:endParaRPr lang="fr-FR"/>
           </a:p>
@@ -5899,7 +5889,7 @@
           <a:p>
             <a:fld id="{F751CFBF-E380-4D91-9539-BDFDF7AF5C45}" type="datetime1">
               <a:rPr lang="fr-FR" smtClean="0"/>
-              <a:t>06/06/2026</a:t>
+              <a:t>08/06/2026</a:t>
             </a:fld>
             <a:endParaRPr lang="fr-FR"/>
           </a:p>
@@ -6069,7 +6059,7 @@
           <a:p>
             <a:fld id="{D2B74F8F-65AC-4766-A2F7-69AD9EC8EDDE}" type="datetime1">
               <a:rPr lang="fr-FR" smtClean="0"/>
-              <a:t>06/06/2026</a:t>
+              <a:t>08/06/2026</a:t>
             </a:fld>
             <a:endParaRPr lang="fr-FR"/>
           </a:p>
@@ -6346,7 +6336,7 @@
           <a:p>
             <a:fld id="{B4EF0BDA-B3DF-4C30-B725-2619B0E62ACD}" type="datetime1">
               <a:rPr lang="fr-FR" smtClean="0"/>
-              <a:t>06/06/2026</a:t>
+              <a:t>08/06/2026</a:t>
             </a:fld>
             <a:endParaRPr lang="fr-FR"/>
           </a:p>
@@ -6757,7 +6747,7 @@
           <a:p>
             <a:fld id="{2BB7BCF4-2F57-44BE-86E1-4D2E12B5FC6A}" type="datetime1">
               <a:rPr lang="fr-FR" smtClean="0"/>
-              <a:t>06/06/2026</a:t>
+              <a:t>08/06/2026</a:t>
             </a:fld>
             <a:endParaRPr lang="fr-FR"/>
           </a:p>
@@ -7234,7 +7224,7 @@
           <a:p>
             <a:fld id="{6321D020-EA2F-4E08-9F19-25238FB1646F}" type="datetime1">
               <a:rPr lang="fr-FR" smtClean="0"/>
-              <a:t>06/06/2026</a:t>
+              <a:t>08/06/2026</a:t>
             </a:fld>
             <a:endParaRPr lang="fr-FR"/>
           </a:p>
@@ -7352,7 +7342,7 @@
           <a:p>
             <a:fld id="{13019C80-4ECC-4A86-ACB8-43004AF15481}" type="datetime1">
               <a:rPr lang="fr-FR" smtClean="0"/>
-              <a:t>06/06/2026</a:t>
+              <a:t>08/06/2026</a:t>
             </a:fld>
             <a:endParaRPr lang="fr-FR"/>
           </a:p>
@@ -7447,7 +7437,7 @@
           <a:p>
             <a:fld id="{D5B1220C-94C3-4D23-98DD-B536DE4A6F2C}" type="datetime1">
               <a:rPr lang="fr-FR" smtClean="0"/>
-              <a:t>06/06/2026</a:t>
+              <a:t>08/06/2026</a:t>
             </a:fld>
             <a:endParaRPr lang="fr-FR"/>
           </a:p>
@@ -7793,7 +7783,7 @@
           <a:p>
             <a:fld id="{D77193F2-5089-4D6D-B951-141B92746967}" type="datetime1">
               <a:rPr lang="fr-FR" smtClean="0"/>
-              <a:t>06/06/2026</a:t>
+              <a:t>08/06/2026</a:t>
             </a:fld>
             <a:endParaRPr lang="fr-FR"/>
           </a:p>
@@ -8191,7 +8181,7 @@
           <a:p>
             <a:fld id="{2155EEFE-CE4B-45B5-811F-7C771B7BD159}" type="datetime1">
               <a:rPr lang="fr-FR" smtClean="0"/>
-              <a:t>06/06/2026</a:t>
+              <a:t>08/06/2026</a:t>
             </a:fld>
             <a:endParaRPr lang="fr-FR"/>
           </a:p>
@@ -8479,7 +8469,7 @@
           <a:p>
             <a:fld id="{8865F967-DFD5-47C5-B34E-026F86C5401C}" type="datetime1">
               <a:rPr lang="fr-FR" smtClean="0"/>
-              <a:t>06/06/2026</a:t>
+              <a:t>08/06/2026</a:t>
             </a:fld>
             <a:endParaRPr lang="fr-FR"/>
           </a:p>
@@ -9559,7 +9549,7 @@
             <p:ph idx="1"/>
             <p:extLst>
               <p:ext uri="{D42A27DB-BD31-4B8C-83A1-F6EECF244321}">
-                <p14:modId xmlns:p14="http://schemas.microsoft.com/office/powerpoint/2010/main" val="3236764502"/>
+                <p14:modId xmlns:p14="http://schemas.microsoft.com/office/powerpoint/2010/main" val="2075648815"/>
               </p:ext>
             </p:extLst>
           </p:nvPr>

</xml_diff>